<commit_message>
Arregla documentos en cuanto al codigo de las pruebas
</commit_message>
<xml_diff>
--- a/entregables/01-Presentacion-Equipo3.pptx
+++ b/entregables/01-Presentacion-Equipo3.pptx
@@ -1113,7 +1113,7 @@
             <a:r>
               <a:rPr lang="en-US" dirty="0"/>
               <a:t>Expone: Gael.
-Dos pruebas más. A la izquierda, P07: S3 puede entregar el mismo evento dos veces, así que lo forzamos. La procesadora escribe con una condición, solo si el id no existe, y el log marca duplicado: queda un solo registro. A la derecha, P08: mientras la base de datos estaba fallando, la web no se quedó colgada ni volvió a mandar la noticia; avisó que la imagen se subió y que la noticia sigue en procesamiento. Cuando se recuperó, apareció una sola vez.</a:t>
+Dos comprobaciones más. A la izquierda, el evento repetido: S3 puede entregar el mismo evento dos veces, así que lo forzamos. La procesadora escribe con una condición, solo si el id no existe, y el log marca duplicado: queda un solo registro. A la derecha, el procesamiento lento: mientras la base de datos estaba fallando, la web no se quedó colgada ni volvió a mandar la noticia; avisó que la imagen se subió y que la noticia sigue en procesamiento. Cuando se recuperó, apareció una sola vez.</a:t>
             </a:r>
             <a:endParaRPr lang="en-US" dirty="0"/>
           </a:p>
@@ -1202,7 +1202,7 @@
             <a:r>
               <a:rPr lang="en-US" dirty="0"/>
               <a:t>Expone: Elisa.
-En resumen, planeamos ocho pruebas: dos de funcionamiento normal y seis de fallas y casos raros. Las ocho pasaron. Todas tienen fecha, hora, id de la noticia y su captura en la matriz de pruebas que entregamos.</a:t>
+En resumen, así fuimos comprobando el sistema. Primero, en condiciones normales: la noticia se publica sola y sigue ahí al recargar. Después, provocando fallos a propósito: una imagen sin datos se descarta, una caída de la base se reintenta y se recupera, la métrica y la alarma lo detectan, un evento repetido no duplica y la web espera sin reenviar. En todos los casos el sistema hizo lo que esperábamos, y cada uno tiene su captura en el manual.</a:t>
             </a:r>
             <a:endParaRPr lang="en-US" dirty="0"/>
           </a:p>
@@ -3466,39 +3466,14 @@
       </p:sp>
       <p:sp>
         <p:nvSpPr>
-          <p:cNvPr id="5" name="caso-1-fondo"/>
-          <p:cNvSpPr/>
-          <p:nvPr/>
-        </p:nvSpPr>
-        <p:spPr>
-          <a:xfrm>
-            <a:off x="777240" y="2011680"/>
-            <a:ext cx="3337560" cy="3794760"/>
-          </a:xfrm>
-          <a:prstGeom prst="rect">
-            <a:avLst/>
-          </a:prstGeom>
-          <a:solidFill>
-            <a:schemeClr val="bg1"/>
-          </a:solidFill>
-          <a:ln w="19050">
-            <a:solidFill>
-              <a:schemeClr val="accent2"/>
-            </a:solidFill>
-            <a:prstDash val="solid"/>
-          </a:ln>
-        </p:spPr>
-      </p:sp>
-      <p:sp>
-        <p:nvSpPr>
           <p:cNvPr id="6" name="num-1"/>
           <p:cNvSpPr txBox="1"/>
           <p:nvPr/>
         </p:nvSpPr>
         <p:spPr>
           <a:xfrm>
-            <a:off x="1051560" y="2286000"/>
-            <a:ext cx="548640" cy="548640"/>
+            <a:off x="6484328" y="1965960"/>
+            <a:ext cx="457200" cy="457200"/>
           </a:xfrm>
           <a:prstGeom prst="rect">
             <a:avLst/>
@@ -3516,7 +3491,7 @@
               <a:buNone/>
             </a:pPr>
             <a:r>
-              <a:rPr lang="en-US" sz="2400" b="1" dirty="0">
+              <a:rPr lang="en-US" sz="2000" b="1" dirty="0">
                 <a:solidFill>
                   <a:schemeClr val="bg1"/>
                 </a:solidFill>
@@ -3535,8 +3510,8 @@
         </p:nvSpPr>
         <p:spPr>
           <a:xfrm>
-            <a:off x="1783080" y="2286000"/>
-            <a:ext cx="2148840" cy="548640"/>
+            <a:off x="7124408" y="1965960"/>
+            <a:ext cx="4259872" cy="457200"/>
           </a:xfrm>
           <a:prstGeom prst="rect">
             <a:avLst/>
@@ -3552,7 +3527,7 @@
               <a:buNone/>
             </a:pPr>
             <a:r>
-              <a:rPr lang="en-US" sz="1900" b="1" dirty="0">
+              <a:rPr lang="en-US" sz="1700" b="1" dirty="0">
                 <a:solidFill>
                   <a:schemeClr val="tx1"/>
                 </a:solidFill>
@@ -3560,42 +3535,6 @@
               <a:t>Carga fallida</a:t>
             </a:r>
             <a:endParaRPr lang="en-US" sz="1900" dirty="0"/>
-          </a:p>
-        </p:txBody>
-      </p:sp>
-      <p:sp>
-        <p:nvSpPr>
-          <p:cNvPr id="8" name="caso-1-sub"/>
-          <p:cNvSpPr txBox="1"/>
-          <p:nvPr/>
-        </p:nvSpPr>
-        <p:spPr>
-          <a:xfrm>
-            <a:off x="1051560" y="3017520"/>
-            <a:ext cx="2788920" cy="365760"/>
-          </a:xfrm>
-          <a:prstGeom prst="rect">
-            <a:avLst/>
-          </a:prstGeom>
-          <a:noFill/>
-          <a:ln/>
-        </p:spPr>
-        <p:txBody>
-          <a:bodyPr wrap="square" lIns="0" tIns="0" rIns="0" bIns="0" rtlCol="0" anchor="ctr"/>
-          <a:lstStyle/>
-          <a:p>
-            <a:pPr indent="0" marL="0">
-              <a:buNone/>
-            </a:pPr>
-            <a:r>
-              <a:rPr lang="en-US" sz="1400" b="1" i="1" dirty="0">
-                <a:solidFill>
-                  <a:schemeClr val="accent3"/>
-                </a:solidFill>
-              </a:rPr>
-              <a:t>La imagen no llega a S3</a:t>
-            </a:r>
-            <a:endParaRPr lang="en-US" sz="1400" dirty="0"/>
           </a:p>
         </p:txBody>
       </p:sp>
@@ -3607,8 +3546,8 @@
         </p:nvSpPr>
         <p:spPr>
           <a:xfrm>
-            <a:off x="1051560" y="3474720"/>
-            <a:ext cx="2788920" cy="2148840"/>
+            <a:off x="7124408" y="2468880"/>
+            <a:ext cx="4259872" cy="777240"/>
           </a:xfrm>
           <a:prstGeom prst="rect">
             <a:avLst/>
@@ -3627,41 +3566,16 @@
               <a:buNone/>
             </a:pPr>
             <a:r>
-              <a:rPr lang="en-US" sz="1500" dirty="0">
+              <a:rPr lang="en-US" sz="1400" dirty="0">
                 <a:solidFill>
                   <a:schemeClr val="tx1"/>
                 </a:solidFill>
               </a:rPr>
               <a:t>No hay evento, así que no se guarda nada a medias. La web muestra el error y el usuario reintenta con el mismo id, sin duplicar.</a:t>
             </a:r>
-            <a:endParaRPr lang="en-US" sz="1500" dirty="0"/>
-          </a:p>
-        </p:txBody>
-      </p:sp>
-      <p:sp>
-        <p:nvSpPr>
-          <p:cNvPr id="10" name="caso-2-fondo"/>
-          <p:cNvSpPr/>
-          <p:nvPr/>
-        </p:nvSpPr>
-        <p:spPr>
-          <a:xfrm>
-            <a:off x="4389120" y="2011680"/>
-            <a:ext cx="3337560" cy="3794760"/>
-          </a:xfrm>
-          <a:prstGeom prst="rect">
-            <a:avLst/>
-          </a:prstGeom>
-          <a:solidFill>
-            <a:schemeClr val="bg1"/>
-          </a:solidFill>
-          <a:ln w="19050">
-            <a:solidFill>
-              <a:schemeClr val="accent2"/>
-            </a:solidFill>
-            <a:prstDash val="solid"/>
-          </a:ln>
-        </p:spPr>
+            <a:endParaRPr lang="en-US" sz="1400" dirty="0"/>
+          </a:p>
+        </p:txBody>
       </p:sp>
       <p:sp>
         <p:nvSpPr>
@@ -3671,8 +3585,8 @@
         </p:nvSpPr>
         <p:spPr>
           <a:xfrm>
-            <a:off x="4663440" y="2286000"/>
-            <a:ext cx="548640" cy="548640"/>
+            <a:off x="6484328" y="3310128"/>
+            <a:ext cx="457200" cy="457200"/>
           </a:xfrm>
           <a:prstGeom prst="rect">
             <a:avLst/>
@@ -3690,7 +3604,7 @@
               <a:buNone/>
             </a:pPr>
             <a:r>
-              <a:rPr lang="en-US" sz="2400" b="1" dirty="0">
+              <a:rPr lang="en-US" sz="2000" b="1" dirty="0">
                 <a:solidFill>
                   <a:schemeClr val="bg1"/>
                 </a:solidFill>
@@ -3709,8 +3623,8 @@
         </p:nvSpPr>
         <p:spPr>
           <a:xfrm>
-            <a:off x="5394960" y="2286000"/>
-            <a:ext cx="2148840" cy="548640"/>
+            <a:off x="7124408" y="3310128"/>
+            <a:ext cx="4259872" cy="457200"/>
           </a:xfrm>
           <a:prstGeom prst="rect">
             <a:avLst/>
@@ -3726,7 +3640,7 @@
               <a:buNone/>
             </a:pPr>
             <a:r>
-              <a:rPr lang="en-US" sz="1900" b="1" dirty="0">
+              <a:rPr lang="en-US" sz="1700" b="1" dirty="0">
                 <a:solidFill>
                   <a:schemeClr val="tx1"/>
                 </a:solidFill>
@@ -3734,42 +3648,6 @@
               <a:t>Imagen sin metadatos</a:t>
             </a:r>
             <a:endParaRPr lang="en-US" sz="1900" dirty="0"/>
-          </a:p>
-        </p:txBody>
-      </p:sp>
-      <p:sp>
-        <p:nvSpPr>
-          <p:cNvPr id="13" name="caso-2-sub"/>
-          <p:cNvSpPr txBox="1"/>
-          <p:nvPr/>
-        </p:nvSpPr>
-        <p:spPr>
-          <a:xfrm>
-            <a:off x="4663440" y="3017520"/>
-            <a:ext cx="2788920" cy="365760"/>
-          </a:xfrm>
-          <a:prstGeom prst="rect">
-            <a:avLst/>
-          </a:prstGeom>
-          <a:noFill/>
-          <a:ln/>
-        </p:spPr>
-        <p:txBody>
-          <a:bodyPr wrap="square" lIns="0" tIns="0" rIns="0" bIns="0" rtlCol="0" anchor="ctr"/>
-          <a:lstStyle/>
-          <a:p>
-            <a:pPr indent="0" marL="0">
-              <a:buNone/>
-            </a:pPr>
-            <a:r>
-              <a:rPr lang="en-US" sz="1400" b="1" i="1" dirty="0">
-                <a:solidFill>
-                  <a:schemeClr val="accent3"/>
-                </a:solidFill>
-              </a:rPr>
-              <a:t>Falta el pendiente con los datos</a:t>
-            </a:r>
-            <a:endParaRPr lang="en-US" sz="1400" dirty="0"/>
           </a:p>
         </p:txBody>
       </p:sp>
@@ -3781,8 +3659,8 @@
         </p:nvSpPr>
         <p:spPr>
           <a:xfrm>
-            <a:off x="4663440" y="3474720"/>
-            <a:ext cx="2788920" cy="2148840"/>
+            <a:off x="7124408" y="3813048"/>
+            <a:ext cx="4259872" cy="777240"/>
           </a:xfrm>
           <a:prstGeom prst="rect">
             <a:avLst/>
@@ -3801,41 +3679,16 @@
               <a:buNone/>
             </a:pPr>
             <a:r>
-              <a:rPr lang="en-US" sz="1500" dirty="0">
+              <a:rPr lang="en-US" sz="1400" dirty="0">
                 <a:solidFill>
                   <a:schemeClr val="tx1"/>
                 </a:solidFill>
               </a:rPr>
-              <a:t>Error terminal: se registra validacion_fallida y no se reintenta, porque repetir no lo arregla. No se crea noticia. (P03)</a:t>
-            </a:r>
-            <a:endParaRPr lang="en-US" sz="1500" dirty="0"/>
-          </a:p>
-        </p:txBody>
-      </p:sp>
-      <p:sp>
-        <p:nvSpPr>
-          <p:cNvPr id="15" name="caso-3-fondo"/>
-          <p:cNvSpPr/>
-          <p:nvPr/>
-        </p:nvSpPr>
-        <p:spPr>
-          <a:xfrm>
-            <a:off x="8001000" y="2011680"/>
-            <a:ext cx="3337560" cy="3794760"/>
-          </a:xfrm>
-          <a:prstGeom prst="rect">
-            <a:avLst/>
-          </a:prstGeom>
-          <a:solidFill>
-            <a:schemeClr val="bg1"/>
-          </a:solidFill>
-          <a:ln w="19050">
-            <a:solidFill>
-              <a:schemeClr val="accent2"/>
-            </a:solidFill>
-            <a:prstDash val="solid"/>
-          </a:ln>
-        </p:spPr>
+              <a:t>Error terminal: se registra validacion_fallida y no se reintenta, porque repetir no lo arregla. No se crea noticia.</a:t>
+            </a:r>
+            <a:endParaRPr lang="en-US" sz="1400" dirty="0"/>
+          </a:p>
+        </p:txBody>
       </p:sp>
       <p:sp>
         <p:nvSpPr>
@@ -3845,8 +3698,8 @@
         </p:nvSpPr>
         <p:spPr>
           <a:xfrm>
-            <a:off x="8275320" y="2286000"/>
-            <a:ext cx="548640" cy="548640"/>
+            <a:off x="6484328" y="4654296"/>
+            <a:ext cx="457200" cy="457200"/>
           </a:xfrm>
           <a:prstGeom prst="rect">
             <a:avLst/>
@@ -3864,7 +3717,7 @@
               <a:buNone/>
             </a:pPr>
             <a:r>
-              <a:rPr lang="en-US" sz="2400" b="1" dirty="0">
+              <a:rPr lang="en-US" sz="2000" b="1" dirty="0">
                 <a:solidFill>
                   <a:schemeClr val="bg1"/>
                 </a:solidFill>
@@ -3883,8 +3736,8 @@
         </p:nvSpPr>
         <p:spPr>
           <a:xfrm>
-            <a:off x="9006840" y="2286000"/>
-            <a:ext cx="2148840" cy="548640"/>
+            <a:off x="7124408" y="4654296"/>
+            <a:ext cx="4259872" cy="457200"/>
           </a:xfrm>
           <a:prstGeom prst="rect">
             <a:avLst/>
@@ -3900,7 +3753,7 @@
               <a:buNone/>
             </a:pPr>
             <a:r>
-              <a:rPr lang="en-US" sz="1900" b="1" dirty="0">
+              <a:rPr lang="en-US" sz="1700" b="1" dirty="0">
                 <a:solidFill>
                   <a:schemeClr val="tx1"/>
                 </a:solidFill>
@@ -3908,42 +3761,6 @@
               <a:t>Falla DynamoDB</a:t>
             </a:r>
             <a:endParaRPr lang="en-US" sz="1900" dirty="0"/>
-          </a:p>
-        </p:txBody>
-      </p:sp>
-      <p:sp>
-        <p:nvSpPr>
-          <p:cNvPr id="18" name="caso-3-sub"/>
-          <p:cNvSpPr txBox="1"/>
-          <p:nvPr/>
-        </p:nvSpPr>
-        <p:spPr>
-          <a:xfrm>
-            <a:off x="8275320" y="3017520"/>
-            <a:ext cx="2788920" cy="365760"/>
-          </a:xfrm>
-          <a:prstGeom prst="rect">
-            <a:avLst/>
-          </a:prstGeom>
-          <a:noFill/>
-          <a:ln/>
-        </p:spPr>
-        <p:txBody>
-          <a:bodyPr wrap="square" lIns="0" tIns="0" rIns="0" bIns="0" rtlCol="0" anchor="ctr"/>
-          <a:lstStyle/>
-          <a:p>
-            <a:pPr indent="0" marL="0">
-              <a:buNone/>
-            </a:pPr>
-            <a:r>
-              <a:rPr lang="en-US" sz="1400" b="1" i="1" dirty="0">
-                <a:solidFill>
-                  <a:schemeClr val="accent3"/>
-                </a:solidFill>
-              </a:rPr>
-              <a:t>No se puede guardar</a:t>
-            </a:r>
-            <a:endParaRPr lang="en-US" sz="1400" dirty="0"/>
           </a:p>
         </p:txBody>
       </p:sp>
@@ -3955,8 +3772,8 @@
         </p:nvSpPr>
         <p:spPr>
           <a:xfrm>
-            <a:off x="8275320" y="3474720"/>
-            <a:ext cx="2788920" cy="2148840"/>
+            <a:off x="7124408" y="5157216"/>
+            <a:ext cx="4259872" cy="777240"/>
           </a:xfrm>
           <a:prstGeom prst="rect">
             <a:avLst/>
@@ -3975,17 +3792,65 @@
               <a:buNone/>
             </a:pPr>
             <a:r>
-              <a:rPr lang="en-US" sz="1500" dirty="0">
+              <a:rPr lang="en-US" sz="1400" dirty="0">
                 <a:solidFill>
                   <a:schemeClr val="tx1"/>
                 </a:solidFill>
               </a:rPr>
-              <a:t>La función relanza el error: sube la métrica Errors, Lambda reintenta 2 veces y la alarma se enciende. Al corregir, se recupera. (P04–P06)</a:t>
-            </a:r>
-            <a:endParaRPr lang="en-US" sz="1500" dirty="0"/>
-          </a:p>
-        </p:txBody>
-      </p:sp>
+              <a:t>La función relanza el error: sube la métrica Errors, Lambda reintenta 2 veces y la alarma se enciende. Al corregir, se recupera.</a:t>
+            </a:r>
+            <a:endParaRPr lang="en-US" sz="1400" dirty="0"/>
+          </a:p>
+        </p:txBody>
+      </p:sp>
+      <p:sp>
+        <p:nvSpPr>
+          <p:cNvPr id="26" name="marco-errores.png"/>
+          <p:cNvSpPr/>
+          <p:nvPr/>
+        </p:nvSpPr>
+        <p:spPr>
+          <a:xfrm>
+            <a:off x="777240" y="1892808"/>
+            <a:ext cx="5277320" cy="4078224"/>
+          </a:xfrm>
+          <a:prstGeom prst="rect">
+            <a:avLst/>
+          </a:prstGeom>
+          <a:solidFill>
+            <a:srgbClr val="FFFFFF"/>
+          </a:solidFill>
+          <a:ln w="19050">
+            <a:solidFill>
+              <a:schemeClr val="accent1"/>
+            </a:solidFill>
+          </a:ln>
+        </p:spPr>
+      </p:sp>
+      <p:pic>
+        <p:nvPicPr>
+          <p:cNvPr id="27" name="img-errores.png" descr="Decisiones de la procesadora ante cada evento"/>
+          <p:cNvPicPr>
+            <a:picLocks noChangeAspect="1"/>
+          </p:cNvPicPr>
+          <p:nvPr/>
+        </p:nvPicPr>
+        <p:blipFill>
+          <a:blip r:embed="rId4"/>
+          <a:stretch>
+            <a:fillRect/>
+          </a:stretch>
+        </p:blipFill>
+        <p:spPr>
+          <a:xfrm>
+            <a:off x="850392" y="1965960"/>
+            <a:ext cx="5131016" cy="3931920"/>
+          </a:xfrm>
+          <a:prstGeom prst="rect">
+            <a:avLst/>
+          </a:prstGeom>
+        </p:spPr>
+      </p:pic>
       <p:sp>
         <p:nvSpPr>
           <p:cNvPr id="25" name="Slide Number Placeholder 0"/>
@@ -4140,7 +4005,7 @@
       </p:sp>
       <p:pic>
         <p:nvPicPr>
-          <p:cNvPr id="5" name="img-p03.png" descr="Prueba P03: validacion_fallida">    </p:cNvPr>
+          <p:cNvPr id="5" name="img-p03.png" descr="Imagen sin datos: validacion_fallida">    </p:cNvPr>
           <p:cNvPicPr>
             <a:picLocks noChangeAspect="1"/>
           </p:cNvPicPr>
@@ -4171,7 +4036,7 @@
         <p:spPr>
           <a:xfrm>
             <a:off x="8366760" y="1828800"/>
-            <a:ext cx="1371600" cy="384048"/>
+            <a:ext cx="1828800" cy="384048"/>
           </a:xfrm>
           <a:prstGeom prst="roundRect">
             <a:avLst>
@@ -4196,7 +4061,7 @@
                   <a:schemeClr val="bg1"/>
                 </a:solidFill>
               </a:rPr>
-              <a:t>P03 ✓</a:t>
+              <a:t>Descartada ✓</a:t>
             </a:r>
             <a:endParaRPr lang="en-US" sz="1400" dirty="0"/>
           </a:p>
@@ -4506,7 +4371,7 @@
       </p:sp>
       <p:pic>
         <p:nvPicPr>
-          <p:cNvPr id="5" name="img-p04.png" descr="Prueba P04: tres intentos con ResourceNotFoundException">    </p:cNvPr>
+          <p:cNvPr id="5" name="img-p04.png" descr="Falla de DynamoDB: tres intentos con ResourceNotFoundException">    </p:cNvPr>
           <p:cNvPicPr>
             <a:picLocks noChangeAspect="1"/>
           </p:cNvPicPr>
@@ -4573,7 +4438,7 @@
         <p:spPr>
           <a:xfrm>
             <a:off x="8183880" y="1828800"/>
-            <a:ext cx="1371600" cy="384048"/>
+            <a:ext cx="1828800" cy="384048"/>
           </a:xfrm>
           <a:prstGeom prst="roundRect">
             <a:avLst>
@@ -4598,7 +4463,7 @@
                   <a:schemeClr val="bg1"/>
                 </a:solidFill>
               </a:rPr>
-              <a:t>P04 ✓</a:t>
+              <a:t>Recuperada ✓</a:t>
             </a:r>
             <a:endParaRPr lang="en-US" sz="1400" dirty="0"/>
           </a:p>
@@ -4945,7 +4810,7 @@
       </p:sp>
       <p:pic>
         <p:nvPicPr>
-          <p:cNvPr id="5" name="img-p05.png" descr="Prueba P05: métricas de Lambda">    </p:cNvPr>
+          <p:cNvPr id="5" name="img-p05.png" descr="Métricas de Lambda durante el fallo">    </p:cNvPr>
           <p:cNvPicPr>
             <a:picLocks noChangeAspect="1"/>
           </p:cNvPicPr>
@@ -4976,7 +4841,7 @@
         <p:spPr>
           <a:xfrm>
             <a:off x="8778240" y="1828800"/>
-            <a:ext cx="1371600" cy="384048"/>
+            <a:ext cx="1828800" cy="384048"/>
           </a:xfrm>
           <a:prstGeom prst="roundRect">
             <a:avLst>
@@ -5001,7 +4866,7 @@
                   <a:schemeClr val="bg1"/>
                 </a:solidFill>
               </a:rPr>
-              <a:t>P05 ✓</a:t>
+              <a:t>Detectado ✓</a:t>
             </a:r>
             <a:endParaRPr lang="en-US" sz="1400" dirty="0"/>
           </a:p>
@@ -5399,7 +5264,7 @@
                   <a:schemeClr val="bg1"/>
                 </a:solidFill>
               </a:rPr>
-              <a:t>P06 ✓</a:t>
+              <a:t>Avisó ✓</a:t>
             </a:r>
             <a:endParaRPr lang="en-US" sz="1400" dirty="0"/>
           </a:p>
@@ -5641,7 +5506,7 @@
       </p:sp>
       <p:pic>
         <p:nvPicPr>
-          <p:cNvPr id="5" name="img-p07.png" descr="Prueba P07: evento duplicado">    </p:cNvPr>
+          <p:cNvPr id="5" name="img-p07.png" descr="Evento repetido: log duplicado">    </p:cNvPr>
           <p:cNvPicPr>
             <a:picLocks noChangeAspect="1"/>
           </p:cNvPicPr>
@@ -5685,7 +5550,7 @@
       </p:sp>
       <p:pic>
         <p:nvPicPr>
-          <p:cNvPr id="7" name="img-p08.png" descr="Prueba P08: la web muestra procesamiento pendiente">    </p:cNvPr>
+          <p:cNvPr id="7" name="img-p08.png" descr="La web muestra procesamiento pendiente">    </p:cNvPr>
           <p:cNvPicPr>
             <a:picLocks noChangeAspect="1"/>
           </p:cNvPicPr>
@@ -5741,7 +5606,7 @@
                   <a:schemeClr val="bg1"/>
                 </a:solidFill>
               </a:rPr>
-              <a:t>P07 ✓  Evento repetido</a:t>
+              <a:t>✓  Evento repetido</a:t>
             </a:r>
             <a:endParaRPr lang="en-US" sz="1400" dirty="0"/>
           </a:p>
@@ -5817,7 +5682,7 @@
                   <a:schemeClr val="bg1"/>
                 </a:solidFill>
               </a:rPr>
-              <a:t>P08 ✓  Procesamiento lento</a:t>
+              <a:t>✓  Procesamiento lento</a:t>
             </a:r>
             <a:endParaRPr lang="en-US" sz="1400" dirty="0"/>
           </a:p>
@@ -5925,7 +5790,7 @@
                   <a:schemeClr val="tx1"/>
                 </a:solidFill>
               </a:rPr>
-              <a:t>8 de 8 pruebas aprobadas</a:t>
+              <a:t>Todo lo que comprobamos</a:t>
             </a:r>
             <a:endParaRPr lang="en-US" sz="3600" dirty="0"/>
           </a:p>
@@ -5989,7 +5854,7 @@
         <p:spPr>
           <a:xfrm>
             <a:off x="1005840" y="1965960"/>
-            <a:ext cx="1188720" cy="548640"/>
+            <a:ext cx="1325880" cy="548640"/>
           </a:xfrm>
           <a:prstGeom prst="rect">
             <a:avLst/>
@@ -6005,14 +5870,14 @@
               <a:buNone/>
             </a:pPr>
             <a:r>
-              <a:rPr lang="en-US" sz="2800" b="1" dirty="0">
+              <a:rPr lang="en-US" sz="1800" b="1" dirty="0">
                 <a:solidFill>
                   <a:schemeClr val="accent1"/>
                 </a:solidFill>
               </a:rPr>
-              <a:t>P01</a:t>
-            </a:r>
-            <a:endParaRPr lang="en-US" sz="2800" dirty="0"/>
+              <a:t>Publicación</a:t>
+            </a:r>
+            <a:endParaRPr lang="en-US" sz="1800" dirty="0"/>
           </a:p>
         </p:txBody>
       </p:sp>
@@ -6063,7 +5928,7 @@
         <p:spPr>
           <a:xfrm>
             <a:off x="1005840" y="2606040"/>
-            <a:ext cx="1874520" cy="411480"/>
+            <a:ext cx="1874520" cy="566928"/>
           </a:xfrm>
           <a:prstGeom prst="rect">
             <a:avLst/>
@@ -6072,21 +5937,21 @@
           <a:ln/>
         </p:spPr>
         <p:txBody>
-          <a:bodyPr wrap="square" lIns="0" tIns="0" rIns="0" bIns="0" rtlCol="0" anchor="ctr"/>
+          <a:bodyPr wrap="square" lIns="0" tIns="0" rIns="0" bIns="0" rtlCol="0" anchor="t"/>
           <a:lstStyle/>
           <a:p>
             <a:pPr indent="0" marL="0">
               <a:buNone/>
             </a:pPr>
             <a:r>
-              <a:rPr lang="en-US" sz="1500" dirty="0">
+              <a:rPr lang="en-US" sz="1400" dirty="0">
                 <a:solidFill>
                   <a:schemeClr val="tx1"/>
                 </a:solidFill>
               </a:rPr>
-              <a:t>Imagen válida</a:t>
-            </a:r>
-            <a:endParaRPr lang="en-US" sz="1500" dirty="0"/>
+              <a:t>S3 activa la procesadora sola</a:t>
+            </a:r>
+            <a:endParaRPr lang="en-US" sz="1400" dirty="0"/>
           </a:p>
         </p:txBody>
       </p:sp>
@@ -6124,7 +5989,7 @@
         <p:spPr>
           <a:xfrm>
             <a:off x="3520440" y="1965960"/>
-            <a:ext cx="1188720" cy="548640"/>
+            <a:ext cx="1325880" cy="548640"/>
           </a:xfrm>
           <a:prstGeom prst="rect">
             <a:avLst/>
@@ -6140,14 +6005,14 @@
               <a:buNone/>
             </a:pPr>
             <a:r>
-              <a:rPr lang="en-US" sz="2800" b="1" dirty="0">
+              <a:rPr lang="en-US" sz="1800" b="1" dirty="0">
                 <a:solidFill>
                   <a:schemeClr val="accent1"/>
                 </a:solidFill>
               </a:rPr>
-              <a:t>P02</a:t>
-            </a:r>
-            <a:endParaRPr lang="en-US" sz="2800" dirty="0"/>
+              <a:t>Guardado</a:t>
+            </a:r>
+            <a:endParaRPr lang="en-US" sz="1800" dirty="0"/>
           </a:p>
         </p:txBody>
       </p:sp>
@@ -6198,7 +6063,7 @@
         <p:spPr>
           <a:xfrm>
             <a:off x="3520440" y="2606040"/>
-            <a:ext cx="1874520" cy="411480"/>
+            <a:ext cx="1874520" cy="566928"/>
           </a:xfrm>
           <a:prstGeom prst="rect">
             <a:avLst/>
@@ -6207,21 +6072,21 @@
           <a:ln/>
         </p:spPr>
         <p:txBody>
-          <a:bodyPr wrap="square" lIns="0" tIns="0" rIns="0" bIns="0" rtlCol="0" anchor="ctr"/>
+          <a:bodyPr wrap="square" lIns="0" tIns="0" rIns="0" bIns="0" rtlCol="0" anchor="t"/>
           <a:lstStyle/>
           <a:p>
             <a:pPr indent="0" marL="0">
               <a:buNone/>
             </a:pPr>
             <a:r>
-              <a:rPr lang="en-US" sz="1500" dirty="0">
+              <a:rPr lang="en-US" sz="1400" dirty="0">
                 <a:solidFill>
                   <a:schemeClr val="tx1"/>
                 </a:solidFill>
               </a:rPr>
-              <a:t>Persistencia</a:t>
-            </a:r>
-            <a:endParaRPr lang="en-US" sz="1500" dirty="0"/>
+              <a:t>La noticia sigue al recargar</a:t>
+            </a:r>
+            <a:endParaRPr lang="en-US" sz="1400" dirty="0"/>
           </a:p>
         </p:txBody>
       </p:sp>
@@ -6259,7 +6124,7 @@
         <p:spPr>
           <a:xfrm>
             <a:off x="6035040" y="1965960"/>
-            <a:ext cx="1188720" cy="548640"/>
+            <a:ext cx="1325880" cy="548640"/>
           </a:xfrm>
           <a:prstGeom prst="rect">
             <a:avLst/>
@@ -6275,14 +6140,14 @@
               <a:buNone/>
             </a:pPr>
             <a:r>
-              <a:rPr lang="en-US" sz="2800" b="1" dirty="0">
+              <a:rPr lang="en-US" sz="1800" b="1" dirty="0">
                 <a:solidFill>
                   <a:schemeClr val="accent1"/>
                 </a:solidFill>
               </a:rPr>
-              <a:t>P03</a:t>
-            </a:r>
-            <a:endParaRPr lang="en-US" sz="2800" dirty="0"/>
+              <a:t>Sin datos</a:t>
+            </a:r>
+            <a:endParaRPr lang="en-US" sz="1800" dirty="0"/>
           </a:p>
         </p:txBody>
       </p:sp>
@@ -6333,7 +6198,7 @@
         <p:spPr>
           <a:xfrm>
             <a:off x="6035040" y="2606040"/>
-            <a:ext cx="1874520" cy="411480"/>
+            <a:ext cx="1874520" cy="566928"/>
           </a:xfrm>
           <a:prstGeom prst="rect">
             <a:avLst/>
@@ -6342,21 +6207,21 @@
           <a:ln/>
         </p:spPr>
         <p:txBody>
-          <a:bodyPr wrap="square" lIns="0" tIns="0" rIns="0" bIns="0" rtlCol="0" anchor="ctr"/>
+          <a:bodyPr wrap="square" lIns="0" tIns="0" rIns="0" bIns="0" rtlCol="0" anchor="t"/>
           <a:lstStyle/>
           <a:p>
             <a:pPr indent="0" marL="0">
               <a:buNone/>
             </a:pPr>
             <a:r>
-              <a:rPr lang="en-US" sz="1500" dirty="0">
+              <a:rPr lang="en-US" sz="1400" dirty="0">
                 <a:solidFill>
                   <a:schemeClr val="tx1"/>
                 </a:solidFill>
               </a:rPr>
-              <a:t>JSON ausente</a:t>
-            </a:r>
-            <a:endParaRPr lang="en-US" sz="1500" dirty="0"/>
+              <a:t>Se descarta sin dejar nada a medias</a:t>
+            </a:r>
+            <a:endParaRPr lang="en-US" sz="1400" dirty="0"/>
           </a:p>
         </p:txBody>
       </p:sp>
@@ -6394,7 +6259,7 @@
         <p:spPr>
           <a:xfrm>
             <a:off x="8549640" y="1965960"/>
-            <a:ext cx="1188720" cy="548640"/>
+            <a:ext cx="1325880" cy="548640"/>
           </a:xfrm>
           <a:prstGeom prst="rect">
             <a:avLst/>
@@ -6410,14 +6275,14 @@
               <a:buNone/>
             </a:pPr>
             <a:r>
-              <a:rPr lang="en-US" sz="2800" b="1" dirty="0">
+              <a:rPr lang="en-US" sz="1800" b="1" dirty="0">
                 <a:solidFill>
                   <a:schemeClr val="accent1"/>
                 </a:solidFill>
               </a:rPr>
-              <a:t>P04</a:t>
-            </a:r>
-            <a:endParaRPr lang="en-US" sz="2800" dirty="0"/>
+              <a:t>Reintentos</a:t>
+            </a:r>
+            <a:endParaRPr lang="en-US" sz="1800" dirty="0"/>
           </a:p>
         </p:txBody>
       </p:sp>
@@ -6468,7 +6333,7 @@
         <p:spPr>
           <a:xfrm>
             <a:off x="8549640" y="2606040"/>
-            <a:ext cx="1874520" cy="411480"/>
+            <a:ext cx="1874520" cy="566928"/>
           </a:xfrm>
           <a:prstGeom prst="rect">
             <a:avLst/>
@@ -6477,21 +6342,21 @@
           <a:ln/>
         </p:spPr>
         <p:txBody>
-          <a:bodyPr wrap="square" lIns="0" tIns="0" rIns="0" bIns="0" rtlCol="0" anchor="ctr"/>
+          <a:bodyPr wrap="square" lIns="0" tIns="0" rIns="0" bIns="0" rtlCol="0" anchor="t"/>
           <a:lstStyle/>
           <a:p>
             <a:pPr indent="0" marL="0">
               <a:buNone/>
             </a:pPr>
             <a:r>
-              <a:rPr lang="en-US" sz="1500" dirty="0">
+              <a:rPr lang="en-US" sz="1400" dirty="0">
                 <a:solidFill>
                   <a:schemeClr val="tx1"/>
                 </a:solidFill>
               </a:rPr>
-              <a:t>Falla DynamoDB</a:t>
-            </a:r>
-            <a:endParaRPr lang="en-US" sz="1500" dirty="0"/>
+              <a:t>La base falla y la noticia se recupera</a:t>
+            </a:r>
+            <a:endParaRPr lang="en-US" sz="1400" dirty="0"/>
           </a:p>
         </p:txBody>
       </p:sp>
@@ -6529,7 +6394,7 @@
         <p:spPr>
           <a:xfrm>
             <a:off x="1005840" y="3657600"/>
-            <a:ext cx="1188720" cy="548640"/>
+            <a:ext cx="1325880" cy="548640"/>
           </a:xfrm>
           <a:prstGeom prst="rect">
             <a:avLst/>
@@ -6545,14 +6410,14 @@
               <a:buNone/>
             </a:pPr>
             <a:r>
-              <a:rPr lang="en-US" sz="2800" b="1" dirty="0">
+              <a:rPr lang="en-US" sz="1800" b="1" dirty="0">
                 <a:solidFill>
                   <a:schemeClr val="accent1"/>
                 </a:solidFill>
               </a:rPr>
-              <a:t>P05</a:t>
-            </a:r>
-            <a:endParaRPr lang="en-US" sz="2800" dirty="0"/>
+              <a:t>Métrica</a:t>
+            </a:r>
+            <a:endParaRPr lang="en-US" sz="1800" dirty="0"/>
           </a:p>
         </p:txBody>
       </p:sp>
@@ -6603,7 +6468,7 @@
         <p:spPr>
           <a:xfrm>
             <a:off x="1005840" y="4297680"/>
-            <a:ext cx="1874520" cy="411480"/>
+            <a:ext cx="1874520" cy="566928"/>
           </a:xfrm>
           <a:prstGeom prst="rect">
             <a:avLst/>
@@ -6612,21 +6477,21 @@
           <a:ln/>
         </p:spPr>
         <p:txBody>
-          <a:bodyPr wrap="square" lIns="0" tIns="0" rIns="0" bIns="0" rtlCol="0" anchor="ctr"/>
+          <a:bodyPr wrap="square" lIns="0" tIns="0" rIns="0" bIns="0" rtlCol="0" anchor="t"/>
           <a:lstStyle/>
           <a:p>
             <a:pPr indent="0" marL="0">
               <a:buNone/>
             </a:pPr>
             <a:r>
-              <a:rPr lang="en-US" sz="1500" dirty="0">
+              <a:rPr lang="en-US" sz="1400" dirty="0">
                 <a:solidFill>
                   <a:schemeClr val="tx1"/>
                 </a:solidFill>
               </a:rPr>
-              <a:t>Métrica Errors</a:t>
-            </a:r>
-            <a:endParaRPr lang="en-US" sz="1500" dirty="0"/>
+              <a:t>Errors registra el pico de fallos</a:t>
+            </a:r>
+            <a:endParaRPr lang="en-US" sz="1400" dirty="0"/>
           </a:p>
         </p:txBody>
       </p:sp>
@@ -6664,7 +6529,7 @@
         <p:spPr>
           <a:xfrm>
             <a:off x="3520440" y="3657600"/>
-            <a:ext cx="1188720" cy="548640"/>
+            <a:ext cx="1325880" cy="548640"/>
           </a:xfrm>
           <a:prstGeom prst="rect">
             <a:avLst/>
@@ -6680,14 +6545,14 @@
               <a:buNone/>
             </a:pPr>
             <a:r>
-              <a:rPr lang="en-US" sz="2800" b="1" dirty="0">
+              <a:rPr lang="en-US" sz="1800" b="1" dirty="0">
                 <a:solidFill>
                   <a:schemeClr val="accent1"/>
                 </a:solidFill>
               </a:rPr>
-              <a:t>P06</a:t>
-            </a:r>
-            <a:endParaRPr lang="en-US" sz="2800" dirty="0"/>
+              <a:t>Alarma</a:t>
+            </a:r>
+            <a:endParaRPr lang="en-US" sz="1800" dirty="0"/>
           </a:p>
         </p:txBody>
       </p:sp>
@@ -6738,7 +6603,7 @@
         <p:spPr>
           <a:xfrm>
             <a:off x="3520440" y="4297680"/>
-            <a:ext cx="1874520" cy="411480"/>
+            <a:ext cx="1874520" cy="566928"/>
           </a:xfrm>
           <a:prstGeom prst="rect">
             <a:avLst/>
@@ -6747,21 +6612,21 @@
           <a:ln/>
         </p:spPr>
         <p:txBody>
-          <a:bodyPr wrap="square" lIns="0" tIns="0" rIns="0" bIns="0" rtlCol="0" anchor="ctr"/>
+          <a:bodyPr wrap="square" lIns="0" tIns="0" rIns="0" bIns="0" rtlCol="0" anchor="t"/>
           <a:lstStyle/>
           <a:p>
             <a:pPr indent="0" marL="0">
               <a:buNone/>
             </a:pPr>
             <a:r>
-              <a:rPr lang="en-US" sz="1500" dirty="0">
+              <a:rPr lang="en-US" sz="1400" dirty="0">
                 <a:solidFill>
                   <a:schemeClr val="tx1"/>
                 </a:solidFill>
               </a:rPr>
-              <a:t>Alarma</a:t>
-            </a:r>
-            <a:endParaRPr lang="en-US" sz="1500" dirty="0"/>
+              <a:t>Se enciende y se apaga sola</a:t>
+            </a:r>
+            <a:endParaRPr lang="en-US" sz="1400" dirty="0"/>
           </a:p>
         </p:txBody>
       </p:sp>
@@ -6799,7 +6664,7 @@
         <p:spPr>
           <a:xfrm>
             <a:off x="6035040" y="3657600"/>
-            <a:ext cx="1188720" cy="548640"/>
+            <a:ext cx="1325880" cy="548640"/>
           </a:xfrm>
           <a:prstGeom prst="rect">
             <a:avLst/>
@@ -6815,14 +6680,14 @@
               <a:buNone/>
             </a:pPr>
             <a:r>
-              <a:rPr lang="en-US" sz="2800" b="1" dirty="0">
+              <a:rPr lang="en-US" sz="1800" b="1" dirty="0">
                 <a:solidFill>
                   <a:schemeClr val="accent1"/>
                 </a:solidFill>
               </a:rPr>
-              <a:t>P07</a:t>
-            </a:r>
-            <a:endParaRPr lang="en-US" sz="2800" dirty="0"/>
+              <a:t>Duplicados</a:t>
+            </a:r>
+            <a:endParaRPr lang="en-US" sz="1800" dirty="0"/>
           </a:p>
         </p:txBody>
       </p:sp>
@@ -6873,7 +6738,7 @@
         <p:spPr>
           <a:xfrm>
             <a:off x="6035040" y="4297680"/>
-            <a:ext cx="1874520" cy="411480"/>
+            <a:ext cx="1874520" cy="566928"/>
           </a:xfrm>
           <a:prstGeom prst="rect">
             <a:avLst/>
@@ -6882,21 +6747,21 @@
           <a:ln/>
         </p:spPr>
         <p:txBody>
-          <a:bodyPr wrap="square" lIns="0" tIns="0" rIns="0" bIns="0" rtlCol="0" anchor="ctr"/>
+          <a:bodyPr wrap="square" lIns="0" tIns="0" rIns="0" bIns="0" rtlCol="0" anchor="t"/>
           <a:lstStyle/>
           <a:p>
             <a:pPr indent="0" marL="0">
               <a:buNone/>
             </a:pPr>
             <a:r>
-              <a:rPr lang="en-US" sz="1500" dirty="0">
+              <a:rPr lang="en-US" sz="1400" dirty="0">
                 <a:solidFill>
                   <a:schemeClr val="tx1"/>
                 </a:solidFill>
               </a:rPr>
-              <a:t>Evento duplicado</a:t>
-            </a:r>
-            <a:endParaRPr lang="en-US" sz="1500" dirty="0"/>
+              <a:t>Un evento repetido no duplica</a:t>
+            </a:r>
+            <a:endParaRPr lang="en-US" sz="1400" dirty="0"/>
           </a:p>
         </p:txBody>
       </p:sp>
@@ -6934,7 +6799,7 @@
         <p:spPr>
           <a:xfrm>
             <a:off x="8549640" y="3657600"/>
-            <a:ext cx="1188720" cy="548640"/>
+            <a:ext cx="1325880" cy="548640"/>
           </a:xfrm>
           <a:prstGeom prst="rect">
             <a:avLst/>
@@ -6950,14 +6815,14 @@
               <a:buNone/>
             </a:pPr>
             <a:r>
-              <a:rPr lang="en-US" sz="2800" b="1" dirty="0">
+              <a:rPr lang="en-US" sz="1800" b="1" dirty="0">
                 <a:solidFill>
                   <a:schemeClr val="accent1"/>
                 </a:solidFill>
               </a:rPr>
-              <a:t>P08</a:t>
-            </a:r>
-            <a:endParaRPr lang="en-US" sz="2800" dirty="0"/>
+              <a:t>Espera</a:t>
+            </a:r>
+            <a:endParaRPr lang="en-US" sz="1800" dirty="0"/>
           </a:p>
         </p:txBody>
       </p:sp>
@@ -7008,7 +6873,7 @@
         <p:spPr>
           <a:xfrm>
             <a:off x="8549640" y="4297680"/>
-            <a:ext cx="1874520" cy="411480"/>
+            <a:ext cx="1874520" cy="566928"/>
           </a:xfrm>
           <a:prstGeom prst="rect">
             <a:avLst/>
@@ -7017,21 +6882,21 @@
           <a:ln/>
         </p:spPr>
         <p:txBody>
-          <a:bodyPr wrap="square" lIns="0" tIns="0" rIns="0" bIns="0" rtlCol="0" anchor="ctr"/>
+          <a:bodyPr wrap="square" lIns="0" tIns="0" rIns="0" bIns="0" rtlCol="0" anchor="t"/>
           <a:lstStyle/>
           <a:p>
             <a:pPr indent="0" marL="0">
               <a:buNone/>
             </a:pPr>
             <a:r>
-              <a:rPr lang="en-US" sz="1500" dirty="0">
+              <a:rPr lang="en-US" sz="1400" dirty="0">
                 <a:solidFill>
                   <a:schemeClr val="tx1"/>
                 </a:solidFill>
               </a:rPr>
-              <a:t>Proceso lento</a:t>
-            </a:r>
-            <a:endParaRPr lang="en-US" sz="1500" dirty="0"/>
+              <a:t>La web espera sin reenviar</a:t>
+            </a:r>
+            <a:endParaRPr lang="en-US" sz="1400" dirty="0"/>
           </a:p>
         </p:txBody>
       </p:sp>
@@ -7065,7 +6930,7 @@
                   <a:schemeClr val="accent6"/>
                 </a:solidFill>
               </a:rPr>
-              <a:t>Ejecutadas el 27 de octubre de 2026 en us-east-2; repetidas el 28 para capturas en alta resolución. Detalle en la matriz de pruebas.</a:t>
+              <a:t>Primero en condiciones normales y después provocando fallos a propósito. 27 de octubre de 2026, región us-east-2.</a:t>
             </a:r>
             <a:endParaRPr lang="en-US" sz="1300" dirty="0"/>
           </a:p>
@@ -8171,7 +8036,7 @@
                   <a:schemeClr val="tx1"/>
                 </a:solidFill>
               </a:rPr>
-              <a:t>Validador de IAM: 0 errores, 0 advertencias. Verificado de nuevo con P03 y P07. Las otras tres Lambdas siguen con PowerUserRole: pendiente para un entorno real.</a:t>
+              <a:t>Validador de IAM: 0 errores, 0 advertencias. Con el rol nuevo repetimos los casos de imagen sin datos y evento repetido. Las otras tres Lambdas siguen con PowerUserRole: pendiente para un entorno real.</a:t>
             </a:r>
             <a:endParaRPr lang="en-US" sz="1300" dirty="0"/>
           </a:p>
@@ -11246,864 +11111,52 @@
       </p:pic>
       <p:sp>
         <p:nvSpPr>
-          <p:cNvPr id="4" name="etiqueta-antes"/>
-          <p:cNvSpPr txBox="1"/>
-          <p:nvPr/>
-        </p:nvSpPr>
-        <p:spPr>
-          <a:xfrm>
-            <a:off x="777240" y="2148840"/>
-            <a:ext cx="1188720" cy="384048"/>
-          </a:xfrm>
-          <a:prstGeom prst="roundRect">
-            <a:avLst>
-              <a:gd name="adj" fmla="val 47619"/>
-            </a:avLst>
+          <p:cNvPr id="26" name="marco-arquitectura.png"/>
+          <p:cNvSpPr/>
+          <p:nvPr/>
+        </p:nvSpPr>
+        <p:spPr>
+          <a:xfrm>
+            <a:off x="2620391" y="1408176"/>
+            <a:ext cx="6950913" cy="4672584"/>
+          </a:xfrm>
+          <a:prstGeom prst="rect">
+            <a:avLst/>
           </a:prstGeom>
           <a:solidFill>
-            <a:schemeClr val="accent3"/>
+            <a:srgbClr val="FFFFFF"/>
           </a:solidFill>
-          <a:ln/>
-        </p:spPr>
-        <p:txBody>
-          <a:bodyPr wrap="square" lIns="0" tIns="0" rIns="0" bIns="0" rtlCol="0" anchor="ctr"/>
-          <a:lstStyle/>
-          <a:p>
-            <a:pPr algn="ctr" indent="0" marL="0">
-              <a:buNone/>
-            </a:pPr>
-            <a:r>
-              <a:rPr lang="en-US" sz="1400" b="1" dirty="0">
-                <a:solidFill>
-                  <a:schemeClr val="bg1"/>
-                </a:solidFill>
-              </a:rPr>
-              <a:t>ANTES</a:t>
-            </a:r>
-            <a:endParaRPr lang="en-US" sz="1400" dirty="0"/>
-          </a:p>
-        </p:txBody>
-      </p:sp>
-      <p:sp>
-        <p:nvSpPr>
-          <p:cNvPr id="5" name="antes-navegador"/>
-          <p:cNvSpPr txBox="1"/>
-          <p:nvPr/>
-        </p:nvSpPr>
-        <p:spPr>
-          <a:xfrm>
-            <a:off x="2377440" y="2057400"/>
-            <a:ext cx="1828800" cy="566928"/>
-          </a:xfrm>
-          <a:prstGeom prst="roundRect">
-            <a:avLst>
-              <a:gd name="adj" fmla="val 16129"/>
-            </a:avLst>
-          </a:prstGeom>
-          <a:solidFill>
-            <a:schemeClr val="bg1"/>
-          </a:solidFill>
-          <a:ln/>
-        </p:spPr>
-        <p:txBody>
-          <a:bodyPr wrap="square" lIns="50800" tIns="50800" rIns="50800" bIns="50800" rtlCol="0" anchor="ctr"/>
-          <a:lstStyle/>
-          <a:p>
-            <a:pPr algn="ctr" indent="0" marL="0">
-              <a:buNone/>
-            </a:pPr>
-            <a:r>
-              <a:rPr lang="en-US" sz="1400" b="1" dirty="0">
-                <a:solidFill>
-                  <a:schemeClr val="tx1"/>
-                </a:solidFill>
-              </a:rPr>
-              <a:t>Navegador</a:t>
-            </a:r>
-            <a:endParaRPr lang="en-US" sz="1400" dirty="0"/>
-          </a:p>
-        </p:txBody>
-      </p:sp>
-      <p:sp>
-        <p:nvSpPr>
-          <p:cNvPr id="6" name="antes-s3"/>
-          <p:cNvSpPr txBox="1"/>
-          <p:nvPr/>
-        </p:nvSpPr>
-        <p:spPr>
-          <a:xfrm>
-            <a:off x="5120640" y="1572768"/>
-            <a:ext cx="1828800" cy="566928"/>
-          </a:xfrm>
-          <a:prstGeom prst="roundRect">
-            <a:avLst>
-              <a:gd name="adj" fmla="val 16129"/>
-            </a:avLst>
-          </a:prstGeom>
-          <a:solidFill>
-            <a:schemeClr val="bg1"/>
-          </a:solidFill>
-          <a:ln/>
-        </p:spPr>
-        <p:txBody>
-          <a:bodyPr wrap="square" lIns="50800" tIns="50800" rIns="50800" bIns="50800" rtlCol="0" anchor="ctr"/>
-          <a:lstStyle/>
-          <a:p>
-            <a:pPr algn="ctr" indent="0" marL="0">
-              <a:buNone/>
-            </a:pPr>
-            <a:r>
-              <a:rPr lang="en-US" sz="1400" b="1" dirty="0">
-                <a:solidFill>
-                  <a:schemeClr val="tx1"/>
-                </a:solidFill>
-              </a:rPr>
-              <a:t>S3 imágenes</a:t>
-            </a:r>
-            <a:endParaRPr lang="en-US" sz="1400" dirty="0"/>
-          </a:p>
-        </p:txBody>
-      </p:sp>
-      <p:sp>
-        <p:nvSpPr>
-          <p:cNvPr id="7" name="antes-agregar"/>
-          <p:cNvSpPr txBox="1"/>
-          <p:nvPr/>
-        </p:nvSpPr>
-        <p:spPr>
-          <a:xfrm>
-            <a:off x="5120640" y="2578608"/>
-            <a:ext cx="1828800" cy="566928"/>
-          </a:xfrm>
-          <a:prstGeom prst="roundRect">
-            <a:avLst>
-              <a:gd name="adj" fmla="val 16129"/>
-            </a:avLst>
-          </a:prstGeom>
-          <a:solidFill>
-            <a:schemeClr val="bg1"/>
-          </a:solidFill>
-          <a:ln/>
-        </p:spPr>
-        <p:txBody>
-          <a:bodyPr wrap="square" lIns="50800" tIns="50800" rIns="50800" bIns="50800" rtlCol="0" anchor="ctr"/>
-          <a:lstStyle/>
-          <a:p>
-            <a:pPr algn="ctr" indent="0" marL="0">
-              <a:buNone/>
-            </a:pPr>
-            <a:r>
-              <a:rPr lang="en-US" sz="1400" b="1" dirty="0">
-                <a:solidFill>
-                  <a:schemeClr val="tx1"/>
-                </a:solidFill>
-              </a:rPr>
-              <a:t>Lambda agregar</a:t>
-            </a:r>
-            <a:endParaRPr lang="en-US" sz="1400" dirty="0"/>
-          </a:p>
-        </p:txBody>
-      </p:sp>
-      <p:sp>
-        <p:nvSpPr>
-          <p:cNvPr id="8" name="antes-dynamo"/>
-          <p:cNvSpPr txBox="1"/>
-          <p:nvPr/>
-        </p:nvSpPr>
-        <p:spPr>
-          <a:xfrm>
-            <a:off x="8001000" y="2578608"/>
-            <a:ext cx="1828800" cy="566928"/>
-          </a:xfrm>
-          <a:prstGeom prst="roundRect">
-            <a:avLst>
-              <a:gd name="adj" fmla="val 16129"/>
-            </a:avLst>
-          </a:prstGeom>
-          <a:solidFill>
-            <a:schemeClr val="bg1"/>
-          </a:solidFill>
-          <a:ln/>
-        </p:spPr>
-        <p:txBody>
-          <a:bodyPr wrap="square" lIns="50800" tIns="50800" rIns="50800" bIns="50800" rtlCol="0" anchor="ctr"/>
-          <a:lstStyle/>
-          <a:p>
-            <a:pPr algn="ctr" indent="0" marL="0">
-              <a:buNone/>
-            </a:pPr>
-            <a:r>
-              <a:rPr lang="en-US" sz="1400" b="1" dirty="0">
-                <a:solidFill>
-                  <a:schemeClr val="tx1"/>
-                </a:solidFill>
-              </a:rPr>
-              <a:t>DynamoDB</a:t>
-            </a:r>
-            <a:endParaRPr lang="en-US" sz="1400" dirty="0"/>
-          </a:p>
-        </p:txBody>
-      </p:sp>
-      <p:sp>
-        <p:nvSpPr>
-          <p:cNvPr id="9" name="antes-f1"/>
-          <p:cNvSpPr/>
-          <p:nvPr/>
-        </p:nvSpPr>
-        <p:spPr>
-          <a:xfrm flipV="1">
-            <a:off x="4206240" y="1856232"/>
-            <a:ext cx="914400" cy="384048"/>
-          </a:xfrm>
-          <a:prstGeom prst="line">
-            <a:avLst/>
-          </a:prstGeom>
-          <a:noFill/>
-          <a:ln w="25400">
+          <a:ln w="19050">
             <a:solidFill>
-              <a:schemeClr val="tx2"/>
+              <a:schemeClr val="accent1"/>
             </a:solidFill>
-            <a:prstDash val="solid"/>
-            <a:tailEnd type="triangle"/>
           </a:ln>
         </p:spPr>
       </p:sp>
-      <p:sp>
-        <p:nvSpPr>
-          <p:cNvPr id="10" name="antes-f2"/>
-          <p:cNvSpPr/>
-          <p:nvPr/>
-        </p:nvSpPr>
-        <p:spPr>
-          <a:xfrm>
-            <a:off x="4206240" y="2514600"/>
-            <a:ext cx="914400" cy="347472"/>
-          </a:xfrm>
-          <a:prstGeom prst="line">
-            <a:avLst/>
-          </a:prstGeom>
-          <a:noFill/>
-          <a:ln w="25400">
-            <a:solidFill>
-              <a:schemeClr val="tx2"/>
-            </a:solidFill>
-            <a:prstDash val="solid"/>
-            <a:tailEnd type="triangle"/>
-          </a:ln>
-        </p:spPr>
-      </p:sp>
-      <p:sp>
-        <p:nvSpPr>
-          <p:cNvPr id="11" name="antes-f3"/>
-          <p:cNvSpPr/>
-          <p:nvPr/>
-        </p:nvSpPr>
-        <p:spPr>
-          <a:xfrm>
-            <a:off x="6949440" y="2862072"/>
-            <a:ext cx="1051560" cy="914"/>
-          </a:xfrm>
-          <a:prstGeom prst="line">
-            <a:avLst/>
-          </a:prstGeom>
-          <a:noFill/>
-          <a:ln w="25400">
-            <a:solidFill>
-              <a:schemeClr val="tx2"/>
-            </a:solidFill>
-            <a:prstDash val="solid"/>
-            <a:tailEnd type="triangle"/>
-          </a:ln>
-        </p:spPr>
-      </p:sp>
-      <p:sp>
-        <p:nvSpPr>
-          <p:cNvPr id="12" name="etiqueta-flecha"/>
-          <p:cNvSpPr txBox="1"/>
-          <p:nvPr/>
-        </p:nvSpPr>
-        <p:spPr>
-          <a:xfrm>
-            <a:off x="3657600" y="1600200"/>
-            <a:ext cx="1463040" cy="274320"/>
-          </a:xfrm>
-          <a:prstGeom prst="rect">
-            <a:avLst/>
-          </a:prstGeom>
-          <a:noFill/>
-          <a:ln/>
-        </p:spPr>
-        <p:txBody>
-          <a:bodyPr wrap="square" lIns="0" tIns="0" rIns="0" bIns="0" rtlCol="0" anchor="ctr"/>
-          <a:lstStyle/>
-          <a:p>
-            <a:pPr algn="ctr" indent="0" marL="0">
-              <a:buNone/>
-            </a:pPr>
-            <a:r>
-              <a:rPr lang="en-US" sz="1100" b="1" dirty="0">
-                <a:solidFill>
-                  <a:schemeClr val="tx2"/>
-                </a:solidFill>
-              </a:rPr>
-              <a:t>① sube foto</a:t>
-            </a:r>
-            <a:endParaRPr lang="en-US" sz="1100" dirty="0"/>
-          </a:p>
-        </p:txBody>
-      </p:sp>
-      <p:sp>
-        <p:nvSpPr>
-          <p:cNvPr id="13" name="etiqueta-flecha"/>
-          <p:cNvSpPr txBox="1"/>
-          <p:nvPr/>
-        </p:nvSpPr>
-        <p:spPr>
-          <a:xfrm>
-            <a:off x="3703320" y="2926080"/>
-            <a:ext cx="1463040" cy="274320"/>
-          </a:xfrm>
-          <a:prstGeom prst="rect">
-            <a:avLst/>
-          </a:prstGeom>
-          <a:noFill/>
-          <a:ln/>
-        </p:spPr>
-        <p:txBody>
-          <a:bodyPr wrap="square" lIns="0" tIns="0" rIns="0" bIns="0" rtlCol="0" anchor="ctr"/>
-          <a:lstStyle/>
-          <a:p>
-            <a:pPr algn="ctr" indent="0" marL="0">
-              <a:buNone/>
-            </a:pPr>
-            <a:r>
-              <a:rPr lang="en-US" sz="1100" b="1" dirty="0">
-                <a:solidFill>
-                  <a:schemeClr val="tx2"/>
-                </a:solidFill>
-              </a:rPr>
-              <a:t>② luego guarda</a:t>
-            </a:r>
-            <a:endParaRPr lang="en-US" sz="1100" dirty="0"/>
-          </a:p>
-        </p:txBody>
-      </p:sp>
-      <p:sp>
-        <p:nvSpPr>
-          <p:cNvPr id="14" name="antes-riesgo"/>
-          <p:cNvSpPr txBox="1"/>
-          <p:nvPr/>
-        </p:nvSpPr>
-        <p:spPr>
-          <a:xfrm>
-            <a:off x="7452360" y="1691640"/>
-            <a:ext cx="3566160" cy="548640"/>
-          </a:xfrm>
-          <a:prstGeom prst="rect">
-            <a:avLst/>
-          </a:prstGeom>
-          <a:noFill/>
-          <a:ln/>
-        </p:spPr>
-        <p:txBody>
-          <a:bodyPr wrap="square" lIns="0" tIns="0" rIns="0" bIns="0" rtlCol="0" anchor="ctr"/>
-          <a:lstStyle/>
-          <a:p>
-            <a:pPr indent="0" marL="0">
-              <a:buNone/>
-            </a:pPr>
-            <a:r>
-              <a:rPr lang="en-US" sz="1300" b="1" dirty="0">
-                <a:solidFill>
-                  <a:schemeClr val="accent4"/>
-                </a:solidFill>
-              </a:rPr>
-              <a:t>Si ② falla: foto sin noticia y nadie se entera</a:t>
-            </a:r>
-            <a:endParaRPr lang="en-US" sz="1300" dirty="0"/>
-          </a:p>
-        </p:txBody>
-      </p:sp>
-      <p:sp>
-        <p:nvSpPr>
-          <p:cNvPr id="15" name="etiqueta-ahora"/>
-          <p:cNvSpPr txBox="1"/>
-          <p:nvPr/>
-        </p:nvSpPr>
-        <p:spPr>
-          <a:xfrm>
-            <a:off x="777240" y="4343400"/>
-            <a:ext cx="1188720" cy="384048"/>
-          </a:xfrm>
-          <a:prstGeom prst="roundRect">
-            <a:avLst>
-              <a:gd name="adj" fmla="val 47619"/>
-            </a:avLst>
-          </a:prstGeom>
-          <a:solidFill>
-            <a:schemeClr val="accent1"/>
-          </a:solidFill>
-          <a:ln/>
-        </p:spPr>
-        <p:txBody>
-          <a:bodyPr wrap="square" lIns="0" tIns="0" rIns="0" bIns="0" rtlCol="0" anchor="ctr"/>
-          <a:lstStyle/>
-          <a:p>
-            <a:pPr algn="ctr" indent="0" marL="0">
-              <a:buNone/>
-            </a:pPr>
-            <a:r>
-              <a:rPr lang="en-US" sz="1400" b="1" dirty="0">
-                <a:solidFill>
-                  <a:schemeClr val="bg1"/>
-                </a:solidFill>
-              </a:rPr>
-              <a:t>AHORA</a:t>
-            </a:r>
-            <a:endParaRPr lang="en-US" sz="1400" dirty="0"/>
-          </a:p>
-        </p:txBody>
-      </p:sp>
-      <p:sp>
-        <p:nvSpPr>
-          <p:cNvPr id="16" name="ahora-navegador"/>
-          <p:cNvSpPr txBox="1"/>
-          <p:nvPr/>
-        </p:nvSpPr>
-        <p:spPr>
-          <a:xfrm>
-            <a:off x="2377440" y="4251960"/>
-            <a:ext cx="1783080" cy="566928"/>
-          </a:xfrm>
-          <a:prstGeom prst="roundRect">
-            <a:avLst>
-              <a:gd name="adj" fmla="val 16129"/>
-            </a:avLst>
-          </a:prstGeom>
-          <a:solidFill>
-            <a:schemeClr val="bg1"/>
-          </a:solidFill>
-          <a:ln/>
-        </p:spPr>
-        <p:txBody>
-          <a:bodyPr wrap="square" lIns="50800" tIns="50800" rIns="50800" bIns="50800" rtlCol="0" anchor="ctr"/>
-          <a:lstStyle/>
-          <a:p>
-            <a:pPr algn="ctr" indent="0" marL="0">
-              <a:buNone/>
-            </a:pPr>
-            <a:r>
-              <a:rPr lang="en-US" sz="1400" b="1" dirty="0">
-                <a:solidFill>
-                  <a:schemeClr val="tx1"/>
-                </a:solidFill>
-              </a:rPr>
-              <a:t>Navegador</a:t>
-            </a:r>
-            <a:endParaRPr lang="en-US" sz="1400" dirty="0"/>
-          </a:p>
-        </p:txBody>
-      </p:sp>
-      <p:sp>
-        <p:nvSpPr>
-          <p:cNvPr id="17" name="ahora-s3"/>
-          <p:cNvSpPr txBox="1"/>
-          <p:nvPr/>
-        </p:nvSpPr>
-        <p:spPr>
-          <a:xfrm>
-            <a:off x="4892040" y="4251960"/>
-            <a:ext cx="1783080" cy="566928"/>
-          </a:xfrm>
-          <a:prstGeom prst="roundRect">
-            <a:avLst>
-              <a:gd name="adj" fmla="val 16129"/>
-            </a:avLst>
-          </a:prstGeom>
-          <a:solidFill>
-            <a:schemeClr val="bg1"/>
-          </a:solidFill>
-          <a:ln/>
-        </p:spPr>
-        <p:txBody>
-          <a:bodyPr wrap="square" lIns="50800" tIns="50800" rIns="50800" bIns="50800" rtlCol="0" anchor="ctr"/>
-          <a:lstStyle/>
-          <a:p>
-            <a:pPr algn="ctr" indent="0" marL="0">
-              <a:buNone/>
-            </a:pPr>
-            <a:r>
-              <a:rPr lang="en-US" sz="1400" b="1" dirty="0">
-                <a:solidFill>
-                  <a:schemeClr val="tx1"/>
-                </a:solidFill>
-              </a:rPr>
-              <a:t>S3 imágenes</a:t>
-            </a:r>
-            <a:endParaRPr lang="en-US" sz="1400" dirty="0"/>
-          </a:p>
-        </p:txBody>
-      </p:sp>
-      <p:sp>
-        <p:nvSpPr>
-          <p:cNvPr id="18" name="ahora-procesadora"/>
-          <p:cNvSpPr txBox="1"/>
-          <p:nvPr/>
-        </p:nvSpPr>
-        <p:spPr>
-          <a:xfrm>
-            <a:off x="7406640" y="4251960"/>
-            <a:ext cx="1783080" cy="566928"/>
-          </a:xfrm>
-          <a:prstGeom prst="roundRect">
-            <a:avLst>
-              <a:gd name="adj" fmla="val 16129"/>
-            </a:avLst>
-          </a:prstGeom>
-          <a:solidFill>
-            <a:schemeClr val="accent1"/>
-          </a:solidFill>
-          <a:ln/>
-        </p:spPr>
-        <p:txBody>
-          <a:bodyPr wrap="square" lIns="50800" tIns="50800" rIns="50800" bIns="50800" rtlCol="0" anchor="ctr"/>
-          <a:lstStyle/>
-          <a:p>
-            <a:pPr algn="ctr" indent="0" marL="0">
-              <a:buNone/>
-            </a:pPr>
-            <a:r>
-              <a:rPr lang="en-US" sz="1400" b="1" dirty="0">
-                <a:solidFill>
-                  <a:schemeClr val="bg1"/>
-                </a:solidFill>
-              </a:rPr>
-              <a:t>Lambda procesadora</a:t>
-            </a:r>
-            <a:endParaRPr lang="en-US" sz="1400" dirty="0"/>
-          </a:p>
-        </p:txBody>
-      </p:sp>
-      <p:sp>
-        <p:nvSpPr>
-          <p:cNvPr id="19" name="ahora-dynamo"/>
-          <p:cNvSpPr txBox="1"/>
-          <p:nvPr/>
-        </p:nvSpPr>
-        <p:spPr>
-          <a:xfrm>
-            <a:off x="9738360" y="4251960"/>
-            <a:ext cx="1600200" cy="566928"/>
-          </a:xfrm>
-          <a:prstGeom prst="roundRect">
-            <a:avLst>
-              <a:gd name="adj" fmla="val 16129"/>
-            </a:avLst>
-          </a:prstGeom>
-          <a:solidFill>
-            <a:schemeClr val="bg1"/>
-          </a:solidFill>
-          <a:ln/>
-        </p:spPr>
-        <p:txBody>
-          <a:bodyPr wrap="square" lIns="50800" tIns="50800" rIns="50800" bIns="50800" rtlCol="0" anchor="ctr"/>
-          <a:lstStyle/>
-          <a:p>
-            <a:pPr algn="ctr" indent="0" marL="0">
-              <a:buNone/>
-            </a:pPr>
-            <a:r>
-              <a:rPr lang="en-US" sz="1400" b="1" dirty="0">
-                <a:solidFill>
-                  <a:schemeClr val="tx1"/>
-                </a:solidFill>
-              </a:rPr>
-              <a:t>DynamoDB</a:t>
-            </a:r>
-            <a:endParaRPr lang="en-US" sz="1400" dirty="0"/>
-          </a:p>
-        </p:txBody>
-      </p:sp>
-      <p:sp>
-        <p:nvSpPr>
-          <p:cNvPr id="20" name="ahora-cloudwatch"/>
-          <p:cNvSpPr txBox="1"/>
-          <p:nvPr/>
-        </p:nvSpPr>
-        <p:spPr>
-          <a:xfrm>
-            <a:off x="6629400" y="5440680"/>
-            <a:ext cx="3337560" cy="502920"/>
-          </a:xfrm>
-          <a:prstGeom prst="roundRect">
-            <a:avLst>
-              <a:gd name="adj" fmla="val 18182"/>
-            </a:avLst>
-          </a:prstGeom>
-          <a:solidFill>
-            <a:schemeClr val="accent2"/>
-          </a:solidFill>
-          <a:ln/>
-        </p:spPr>
-        <p:txBody>
-          <a:bodyPr wrap="square" lIns="50800" tIns="50800" rIns="50800" bIns="50800" rtlCol="0" anchor="ctr"/>
-          <a:lstStyle/>
-          <a:p>
-            <a:pPr algn="ctr" indent="0" marL="0">
-              <a:buNone/>
-            </a:pPr>
-            <a:r>
-              <a:rPr lang="en-US" sz="1400" b="1" dirty="0">
-                <a:solidFill>
-                  <a:schemeClr val="tx1"/>
-                </a:solidFill>
-              </a:rPr>
-              <a:t>CloudWatch · logs · Errors · alarma</a:t>
-            </a:r>
-            <a:endParaRPr lang="en-US" sz="1400" dirty="0"/>
-          </a:p>
-        </p:txBody>
-      </p:sp>
-      <p:sp>
-        <p:nvSpPr>
-          <p:cNvPr id="21" name="ahora-f1"/>
-          <p:cNvSpPr/>
-          <p:nvPr/>
-        </p:nvSpPr>
-        <p:spPr>
-          <a:xfrm>
-            <a:off x="4160520" y="4535424"/>
-            <a:ext cx="731520" cy="914"/>
-          </a:xfrm>
-          <a:prstGeom prst="line">
-            <a:avLst/>
-          </a:prstGeom>
-          <a:noFill/>
-          <a:ln w="25400">
-            <a:solidFill>
-              <a:schemeClr val="tx2"/>
-            </a:solidFill>
-            <a:prstDash val="solid"/>
-            <a:tailEnd type="triangle"/>
-          </a:ln>
-        </p:spPr>
-      </p:sp>
-      <p:sp>
-        <p:nvSpPr>
-          <p:cNvPr id="22" name="ahora-f2"/>
-          <p:cNvSpPr/>
-          <p:nvPr/>
-        </p:nvSpPr>
-        <p:spPr>
-          <a:xfrm>
-            <a:off x="6675120" y="4535424"/>
-            <a:ext cx="731520" cy="914"/>
-          </a:xfrm>
-          <a:prstGeom prst="line">
-            <a:avLst/>
-          </a:prstGeom>
-          <a:noFill/>
-          <a:ln w="31750">
-            <a:solidFill>
-              <a:schemeClr val="accent4"/>
-            </a:solidFill>
-            <a:prstDash val="solid"/>
-            <a:tailEnd type="triangle"/>
-          </a:ln>
-        </p:spPr>
-      </p:sp>
-      <p:sp>
-        <p:nvSpPr>
-          <p:cNvPr id="23" name="ahora-f3"/>
-          <p:cNvSpPr/>
-          <p:nvPr/>
-        </p:nvSpPr>
-        <p:spPr>
-          <a:xfrm>
-            <a:off x="9189720" y="4535424"/>
-            <a:ext cx="548640" cy="914"/>
-          </a:xfrm>
-          <a:prstGeom prst="line">
-            <a:avLst/>
-          </a:prstGeom>
-          <a:noFill/>
-          <a:ln w="25400">
-            <a:solidFill>
-              <a:schemeClr val="tx2"/>
-            </a:solidFill>
-            <a:prstDash val="solid"/>
-            <a:tailEnd type="triangle"/>
-          </a:ln>
-        </p:spPr>
-      </p:sp>
-      <p:sp>
-        <p:nvSpPr>
-          <p:cNvPr id="24" name="ahora-f4"/>
-          <p:cNvSpPr/>
-          <p:nvPr/>
-        </p:nvSpPr>
-        <p:spPr>
-          <a:xfrm>
-            <a:off x="8298180" y="4818888"/>
-            <a:ext cx="914" cy="621792"/>
-          </a:xfrm>
-          <a:prstGeom prst="line">
-            <a:avLst/>
-          </a:prstGeom>
-          <a:noFill/>
-          <a:ln w="25400">
-            <a:solidFill>
-              <a:schemeClr val="accent3"/>
-            </a:solidFill>
-            <a:prstDash val="dash"/>
-            <a:tailEnd type="triangle"/>
-          </a:ln>
-        </p:spPr>
-      </p:sp>
-      <p:sp>
-        <p:nvSpPr>
-          <p:cNvPr id="25" name="etiqueta-flecha"/>
-          <p:cNvSpPr txBox="1"/>
-          <p:nvPr/>
-        </p:nvSpPr>
-        <p:spPr>
-          <a:xfrm>
-            <a:off x="4114800" y="3931920"/>
-            <a:ext cx="822960" cy="274320"/>
-          </a:xfrm>
-          <a:prstGeom prst="rect">
-            <a:avLst/>
-          </a:prstGeom>
-          <a:noFill/>
-          <a:ln/>
-        </p:spPr>
-        <p:txBody>
-          <a:bodyPr wrap="square" lIns="0" tIns="0" rIns="0" bIns="0" rtlCol="0" anchor="ctr"/>
-          <a:lstStyle/>
-          <a:p>
-            <a:pPr algn="ctr" indent="0" marL="0">
-              <a:buNone/>
-            </a:pPr>
-            <a:r>
-              <a:rPr lang="en-US" sz="1100" b="1" dirty="0">
-                <a:solidFill>
-                  <a:schemeClr val="tx2"/>
-                </a:solidFill>
-              </a:rPr>
-              <a:t>sube foto</a:t>
-            </a:r>
-            <a:endParaRPr lang="en-US" sz="1100" dirty="0"/>
-          </a:p>
-        </p:txBody>
-      </p:sp>
-      <p:sp>
-        <p:nvSpPr>
-          <p:cNvPr id="26" name="etiqueta-flecha"/>
-          <p:cNvSpPr txBox="1"/>
-          <p:nvPr/>
-        </p:nvSpPr>
-        <p:spPr>
-          <a:xfrm>
-            <a:off x="6629400" y="3931920"/>
-            <a:ext cx="822960" cy="274320"/>
-          </a:xfrm>
-          <a:prstGeom prst="rect">
-            <a:avLst/>
-          </a:prstGeom>
-          <a:noFill/>
-          <a:ln/>
-        </p:spPr>
-        <p:txBody>
-          <a:bodyPr wrap="square" lIns="0" tIns="0" rIns="0" bIns="0" rtlCol="0" anchor="ctr"/>
-          <a:lstStyle/>
-          <a:p>
-            <a:pPr algn="ctr" indent="0" marL="0">
-              <a:buNone/>
-            </a:pPr>
-            <a:r>
-              <a:rPr lang="en-US" sz="1100" b="1" dirty="0">
-                <a:solidFill>
-                  <a:schemeClr val="accent4"/>
-                </a:solidFill>
-              </a:rPr>
-              <a:t>evento</a:t>
-            </a:r>
-            <a:endParaRPr lang="en-US" sz="1100" dirty="0"/>
-          </a:p>
-        </p:txBody>
-      </p:sp>
-      <p:sp>
-        <p:nvSpPr>
-          <p:cNvPr id="27" name="etiqueta-flecha"/>
-          <p:cNvSpPr txBox="1"/>
-          <p:nvPr/>
-        </p:nvSpPr>
-        <p:spPr>
-          <a:xfrm>
-            <a:off x="9144000" y="3931920"/>
-            <a:ext cx="640080" cy="274320"/>
-          </a:xfrm>
-          <a:prstGeom prst="rect">
-            <a:avLst/>
-          </a:prstGeom>
-          <a:noFill/>
-          <a:ln/>
-        </p:spPr>
-        <p:txBody>
-          <a:bodyPr wrap="square" lIns="0" tIns="0" rIns="0" bIns="0" rtlCol="0" anchor="ctr"/>
-          <a:lstStyle/>
-          <a:p>
-            <a:pPr algn="ctr" indent="0" marL="0">
-              <a:buNone/>
-            </a:pPr>
-            <a:r>
-              <a:rPr lang="en-US" sz="1100" b="1" dirty="0">
-                <a:solidFill>
-                  <a:schemeClr val="tx2"/>
-                </a:solidFill>
-              </a:rPr>
-              <a:t>guarda</a:t>
-            </a:r>
-            <a:endParaRPr lang="en-US" sz="1100" dirty="0"/>
-          </a:p>
-        </p:txBody>
-      </p:sp>
-      <p:sp>
-        <p:nvSpPr>
-          <p:cNvPr id="28" name="ahora-beneficio"/>
-          <p:cNvSpPr txBox="1"/>
-          <p:nvPr/>
-        </p:nvSpPr>
-        <p:spPr>
-          <a:xfrm>
-            <a:off x="2377440" y="5440680"/>
-            <a:ext cx="4206240" cy="502920"/>
-          </a:xfrm>
-          <a:prstGeom prst="rect">
-            <a:avLst/>
-          </a:prstGeom>
-          <a:noFill/>
-          <a:ln/>
-        </p:spPr>
-        <p:txBody>
-          <a:bodyPr wrap="square" lIns="0" tIns="0" rIns="0" bIns="0" rtlCol="0" anchor="ctr"/>
-          <a:lstStyle/>
-          <a:p>
-            <a:pPr indent="0" marL="0">
-              <a:buNone/>
-            </a:pPr>
-            <a:r>
-              <a:rPr lang="en-US" sz="1300" b="1" dirty="0">
-                <a:solidFill>
-                  <a:schemeClr val="accent5"/>
-                </a:solidFill>
-              </a:rPr>
-              <a:t>La nube reacciona sola y cada paso deja rastro</a:t>
-            </a:r>
-            <a:endParaRPr lang="en-US" sz="1300" dirty="0"/>
-          </a:p>
-        </p:txBody>
-      </p:sp>
+      <p:pic>
+        <p:nvPicPr>
+          <p:cNvPr id="27" name="img-arquitectura.png" descr="Arquitectura antes y ahora: el navegador coordinaba; ahora el evento de S3 dispara la procesadora"/>
+          <p:cNvPicPr>
+            <a:picLocks noChangeAspect="1"/>
+          </p:cNvPicPr>
+          <p:nvPr/>
+        </p:nvPicPr>
+        <p:blipFill>
+          <a:blip r:embed="rId4"/>
+          <a:stretch>
+            <a:fillRect/>
+          </a:stretch>
+        </p:blipFill>
+        <p:spPr>
+          <a:xfrm>
+            <a:off x="2693543" y="1481328"/>
+            <a:ext cx="6804609" cy="4526280"/>
+          </a:xfrm>
+          <a:prstGeom prst="rect">
+            <a:avLst/>
+          </a:prstGeom>
+        </p:spPr>
+      </p:pic>
       <p:sp>
         <p:nvSpPr>
           <p:cNvPr id="25" name="Slide Number Placeholder 0"/>
@@ -12238,456 +11291,52 @@
       </p:pic>
       <p:sp>
         <p:nvSpPr>
-          <p:cNvPr id="4" name="num-1"/>
-          <p:cNvSpPr txBox="1"/>
-          <p:nvPr/>
-        </p:nvSpPr>
-        <p:spPr>
-          <a:xfrm>
-            <a:off x="960120" y="1783080"/>
-            <a:ext cx="640080" cy="640080"/>
+          <p:cNvPr id="26" name="marco-secuencia.png"/>
+          <p:cNvSpPr/>
+          <p:nvPr/>
+        </p:nvSpPr>
+        <p:spPr>
+          <a:xfrm>
+            <a:off x="2343058" y="1408176"/>
+            <a:ext cx="7505579" cy="4672584"/>
           </a:xfrm>
           <a:prstGeom prst="rect">
             <a:avLst/>
           </a:prstGeom>
           <a:solidFill>
-            <a:schemeClr val="accent1"/>
+            <a:srgbClr val="FFFFFF"/>
           </a:solidFill>
-          <a:ln/>
-        </p:spPr>
-        <p:txBody>
-          <a:bodyPr wrap="square" lIns="0" tIns="0" rIns="0" bIns="0" rtlCol="0" anchor="ctr"/>
-          <a:lstStyle/>
-          <a:p>
-            <a:pPr algn="ctr" indent="0" marL="0">
-              <a:buNone/>
-            </a:pPr>
-            <a:r>
-              <a:rPr lang="en-US" sz="2800" b="1" dirty="0">
-                <a:solidFill>
-                  <a:schemeClr val="bg1"/>
-                </a:solidFill>
-              </a:rPr>
-              <a:t>1</a:t>
-            </a:r>
-            <a:endParaRPr lang="en-US" sz="2800" dirty="0"/>
-          </a:p>
-        </p:txBody>
-      </p:sp>
-      <p:sp>
-        <p:nvSpPr>
-          <p:cNvPr id="5" name="paso-1-titulo"/>
-          <p:cNvSpPr txBox="1"/>
-          <p:nvPr/>
-        </p:nvSpPr>
-        <p:spPr>
-          <a:xfrm>
-            <a:off x="1828800" y="1764792"/>
-            <a:ext cx="4206240" cy="457200"/>
-          </a:xfrm>
-          <a:prstGeom prst="rect">
-            <a:avLst/>
-          </a:prstGeom>
-          <a:noFill/>
-          <a:ln/>
-        </p:spPr>
-        <p:txBody>
-          <a:bodyPr wrap="square" lIns="0" tIns="0" rIns="0" bIns="0" rtlCol="0" anchor="ctr"/>
-          <a:lstStyle/>
-          <a:p>
-            <a:pPr indent="0" marL="0">
-              <a:buNone/>
-            </a:pPr>
-            <a:r>
-              <a:rPr lang="en-US" sz="1900" b="1" dirty="0">
-                <a:solidFill>
-                  <a:schemeClr val="tx1"/>
-                </a:solidFill>
-              </a:rPr>
-              <a:t>La web pide permiso</a:t>
-            </a:r>
-            <a:endParaRPr lang="en-US" sz="1900" dirty="0"/>
-          </a:p>
-        </p:txBody>
-      </p:sp>
-      <p:sp>
-        <p:nvSpPr>
-          <p:cNvPr id="6" name="paso-1-texto"/>
-          <p:cNvSpPr txBox="1"/>
-          <p:nvPr/>
-        </p:nvSpPr>
-        <p:spPr>
-          <a:xfrm>
-            <a:off x="1828800" y="2258568"/>
-            <a:ext cx="4206240" cy="1280160"/>
-          </a:xfrm>
-          <a:prstGeom prst="rect">
-            <a:avLst/>
-          </a:prstGeom>
-          <a:noFill/>
-          <a:ln/>
-        </p:spPr>
-        <p:txBody>
-          <a:bodyPr wrap="square" lIns="0" tIns="0" rIns="0" bIns="0" rtlCol="0" anchor="t"/>
-          <a:lstStyle/>
-          <a:p>
-            <a:pPr indent="0" marL="0">
-              <a:lnSpc>
-                <a:spcPct val="110000"/>
-              </a:lnSpc>
-              <a:buNone/>
-            </a:pPr>
-            <a:r>
-              <a:rPr lang="en-US" sz="1500" dirty="0">
-                <a:solidFill>
-                  <a:schemeClr val="tx1"/>
-                </a:solidFill>
-              </a:rPr>
-              <a:t>Envía título, fecha y detalle a la Lambda cors. Ella guarda los datos en S3 como «pendiente» y devuelve una URL prefirmada (un permiso temporal para subir).</a:t>
-            </a:r>
-            <a:endParaRPr lang="en-US" sz="1500" dirty="0"/>
-          </a:p>
-        </p:txBody>
-      </p:sp>
-      <p:sp>
-        <p:nvSpPr>
-          <p:cNvPr id="7" name="num-2"/>
-          <p:cNvSpPr txBox="1"/>
-          <p:nvPr/>
-        </p:nvSpPr>
-        <p:spPr>
-          <a:xfrm>
-            <a:off x="6309360" y="1783080"/>
-            <a:ext cx="640080" cy="640080"/>
-          </a:xfrm>
-          <a:prstGeom prst="rect">
-            <a:avLst/>
-          </a:prstGeom>
-          <a:solidFill>
-            <a:schemeClr val="accent1"/>
-          </a:solidFill>
-          <a:ln/>
-        </p:spPr>
-        <p:txBody>
-          <a:bodyPr wrap="square" lIns="0" tIns="0" rIns="0" bIns="0" rtlCol="0" anchor="ctr"/>
-          <a:lstStyle/>
-          <a:p>
-            <a:pPr algn="ctr" indent="0" marL="0">
-              <a:buNone/>
-            </a:pPr>
-            <a:r>
-              <a:rPr lang="en-US" sz="2800" b="1" dirty="0">
-                <a:solidFill>
-                  <a:schemeClr val="bg1"/>
-                </a:solidFill>
-              </a:rPr>
-              <a:t>2</a:t>
-            </a:r>
-            <a:endParaRPr lang="en-US" sz="2800" dirty="0"/>
-          </a:p>
-        </p:txBody>
-      </p:sp>
-      <p:sp>
-        <p:nvSpPr>
-          <p:cNvPr id="8" name="paso-2-titulo"/>
-          <p:cNvSpPr txBox="1"/>
-          <p:nvPr/>
-        </p:nvSpPr>
-        <p:spPr>
-          <a:xfrm>
-            <a:off x="7178040" y="1764792"/>
-            <a:ext cx="4206240" cy="457200"/>
-          </a:xfrm>
-          <a:prstGeom prst="rect">
-            <a:avLst/>
-          </a:prstGeom>
-          <a:noFill/>
-          <a:ln/>
-        </p:spPr>
-        <p:txBody>
-          <a:bodyPr wrap="square" lIns="0" tIns="0" rIns="0" bIns="0" rtlCol="0" anchor="ctr"/>
-          <a:lstStyle/>
-          <a:p>
-            <a:pPr indent="0" marL="0">
-              <a:buNone/>
-            </a:pPr>
-            <a:r>
-              <a:rPr lang="en-US" sz="1900" b="1" dirty="0">
-                <a:solidFill>
-                  <a:schemeClr val="tx1"/>
-                </a:solidFill>
-              </a:rPr>
-              <a:t>La foto sube directo a S3</a:t>
-            </a:r>
-            <a:endParaRPr lang="en-US" sz="1900" dirty="0"/>
-          </a:p>
-        </p:txBody>
-      </p:sp>
-      <p:sp>
-        <p:nvSpPr>
-          <p:cNvPr id="9" name="paso-2-texto"/>
-          <p:cNvSpPr txBox="1"/>
-          <p:nvPr/>
-        </p:nvSpPr>
-        <p:spPr>
-          <a:xfrm>
-            <a:off x="7178040" y="2258568"/>
-            <a:ext cx="4206240" cy="1280160"/>
-          </a:xfrm>
-          <a:prstGeom prst="rect">
-            <a:avLst/>
-          </a:prstGeom>
-          <a:noFill/>
-          <a:ln/>
-        </p:spPr>
-        <p:txBody>
-          <a:bodyPr wrap="square" lIns="0" tIns="0" rIns="0" bIns="0" rtlCol="0" anchor="t"/>
-          <a:lstStyle/>
-          <a:p>
-            <a:pPr indent="0" marL="0">
-              <a:lnSpc>
-                <a:spcPct val="110000"/>
-              </a:lnSpc>
-              <a:buNone/>
-            </a:pPr>
-            <a:r>
-              <a:rPr lang="en-US" sz="1500" dirty="0">
-                <a:solidFill>
-                  <a:schemeClr val="tx1"/>
-                </a:solidFill>
-              </a:rPr>
-              <a:t>El navegador sube la imagen con esa URL a imagenes/ID/foto. Ya no llama a la Lambda de agregar.</a:t>
-            </a:r>
-            <a:endParaRPr lang="en-US" sz="1500" dirty="0"/>
-          </a:p>
-        </p:txBody>
-      </p:sp>
-      <p:sp>
-        <p:nvSpPr>
-          <p:cNvPr id="10" name="num-3"/>
-          <p:cNvSpPr txBox="1"/>
-          <p:nvPr/>
-        </p:nvSpPr>
-        <p:spPr>
-          <a:xfrm>
-            <a:off x="960120" y="3886200"/>
-            <a:ext cx="640080" cy="640080"/>
-          </a:xfrm>
-          <a:prstGeom prst="rect">
-            <a:avLst/>
-          </a:prstGeom>
-          <a:solidFill>
-            <a:schemeClr val="accent2"/>
-          </a:solidFill>
-          <a:ln/>
-        </p:spPr>
-        <p:txBody>
-          <a:bodyPr wrap="square" lIns="0" tIns="0" rIns="0" bIns="0" rtlCol="0" anchor="ctr"/>
-          <a:lstStyle/>
-          <a:p>
-            <a:pPr algn="ctr" indent="0" marL="0">
-              <a:buNone/>
-            </a:pPr>
-            <a:r>
-              <a:rPr lang="en-US" sz="2800" b="1" dirty="0">
-                <a:solidFill>
-                  <a:schemeClr val="tx1"/>
-                </a:solidFill>
-              </a:rPr>
-              <a:t>3</a:t>
-            </a:r>
-            <a:endParaRPr lang="en-US" sz="2800" dirty="0"/>
-          </a:p>
-        </p:txBody>
-      </p:sp>
-      <p:sp>
-        <p:nvSpPr>
-          <p:cNvPr id="11" name="paso-3-titulo"/>
-          <p:cNvSpPr txBox="1"/>
-          <p:nvPr/>
-        </p:nvSpPr>
-        <p:spPr>
-          <a:xfrm>
-            <a:off x="1828800" y="3867912"/>
-            <a:ext cx="4206240" cy="457200"/>
-          </a:xfrm>
-          <a:prstGeom prst="rect">
-            <a:avLst/>
-          </a:prstGeom>
-          <a:noFill/>
-          <a:ln/>
-        </p:spPr>
-        <p:txBody>
-          <a:bodyPr wrap="square" lIns="0" tIns="0" rIns="0" bIns="0" rtlCol="0" anchor="ctr"/>
-          <a:lstStyle/>
-          <a:p>
-            <a:pPr indent="0" marL="0">
-              <a:buNone/>
-            </a:pPr>
-            <a:r>
-              <a:rPr lang="en-US" sz="1900" b="1" dirty="0">
-                <a:solidFill>
-                  <a:schemeClr val="tx1"/>
-                </a:solidFill>
-              </a:rPr>
-              <a:t>S3 despierta a la procesadora</a:t>
-            </a:r>
-            <a:endParaRPr lang="en-US" sz="1900" dirty="0"/>
-          </a:p>
-        </p:txBody>
-      </p:sp>
-      <p:sp>
-        <p:nvSpPr>
-          <p:cNvPr id="12" name="paso-3-texto"/>
-          <p:cNvSpPr txBox="1"/>
-          <p:nvPr/>
-        </p:nvSpPr>
-        <p:spPr>
-          <a:xfrm>
-            <a:off x="1828800" y="4361688"/>
-            <a:ext cx="4206240" cy="1280160"/>
-          </a:xfrm>
-          <a:prstGeom prst="rect">
-            <a:avLst/>
-          </a:prstGeom>
-          <a:noFill/>
-          <a:ln/>
-        </p:spPr>
-        <p:txBody>
-          <a:bodyPr wrap="square" lIns="0" tIns="0" rIns="0" bIns="0" rtlCol="0" anchor="t"/>
-          <a:lstStyle/>
-          <a:p>
-            <a:pPr indent="0" marL="0">
-              <a:lnSpc>
-                <a:spcPct val="110000"/>
-              </a:lnSpc>
-              <a:buNone/>
-            </a:pPr>
-            <a:r>
-              <a:rPr lang="en-US" sz="1500" dirty="0">
-                <a:solidFill>
-                  <a:schemeClr val="tx1"/>
-                </a:solidFill>
-              </a:rPr>
-              <a:t>El evento «objeto creado» en imagenes/ invoca procesar-imagen-noticia automáticamente.</a:t>
-            </a:r>
-            <a:endParaRPr lang="en-US" sz="1500" dirty="0"/>
-          </a:p>
-        </p:txBody>
-      </p:sp>
-      <p:sp>
-        <p:nvSpPr>
-          <p:cNvPr id="13" name="num-4"/>
-          <p:cNvSpPr txBox="1"/>
-          <p:nvPr/>
-        </p:nvSpPr>
-        <p:spPr>
-          <a:xfrm>
-            <a:off x="6309360" y="3886200"/>
-            <a:ext cx="640080" cy="640080"/>
-          </a:xfrm>
-          <a:prstGeom prst="rect">
-            <a:avLst/>
-          </a:prstGeom>
-          <a:solidFill>
-            <a:schemeClr val="accent1"/>
-          </a:solidFill>
-          <a:ln/>
-        </p:spPr>
-        <p:txBody>
-          <a:bodyPr wrap="square" lIns="0" tIns="0" rIns="0" bIns="0" rtlCol="0" anchor="ctr"/>
-          <a:lstStyle/>
-          <a:p>
-            <a:pPr algn="ctr" indent="0" marL="0">
-              <a:buNone/>
-            </a:pPr>
-            <a:r>
-              <a:rPr lang="en-US" sz="2800" b="1" dirty="0">
-                <a:solidFill>
-                  <a:schemeClr val="bg1"/>
-                </a:solidFill>
-              </a:rPr>
-              <a:t>4</a:t>
-            </a:r>
-            <a:endParaRPr lang="en-US" sz="2800" dirty="0"/>
-          </a:p>
-        </p:txBody>
-      </p:sp>
-      <p:sp>
-        <p:nvSpPr>
-          <p:cNvPr id="14" name="paso-4-titulo"/>
-          <p:cNvSpPr txBox="1"/>
-          <p:nvPr/>
-        </p:nvSpPr>
-        <p:spPr>
-          <a:xfrm>
-            <a:off x="7178040" y="3867912"/>
-            <a:ext cx="4206240" cy="457200"/>
-          </a:xfrm>
-          <a:prstGeom prst="rect">
-            <a:avLst/>
-          </a:prstGeom>
-          <a:noFill/>
-          <a:ln/>
-        </p:spPr>
-        <p:txBody>
-          <a:bodyPr wrap="square" lIns="0" tIns="0" rIns="0" bIns="0" rtlCol="0" anchor="ctr"/>
-          <a:lstStyle/>
-          <a:p>
-            <a:pPr indent="0" marL="0">
-              <a:buNone/>
-            </a:pPr>
-            <a:r>
-              <a:rPr lang="en-US" sz="1900" b="1" dirty="0">
-                <a:solidFill>
-                  <a:schemeClr val="tx1"/>
-                </a:solidFill>
-              </a:rPr>
-              <a:t>Valida, guarda y avisa</a:t>
-            </a:r>
-            <a:endParaRPr lang="en-US" sz="1900" dirty="0"/>
-          </a:p>
-        </p:txBody>
-      </p:sp>
-      <p:sp>
-        <p:nvSpPr>
-          <p:cNvPr id="15" name="paso-4-texto"/>
-          <p:cNvSpPr txBox="1"/>
-          <p:nvPr/>
-        </p:nvSpPr>
-        <p:spPr>
-          <a:xfrm>
-            <a:off x="7178040" y="4361688"/>
-            <a:ext cx="4206240" cy="1280160"/>
-          </a:xfrm>
-          <a:prstGeom prst="rect">
-            <a:avLst/>
-          </a:prstGeom>
-          <a:noFill/>
-          <a:ln/>
-        </p:spPr>
-        <p:txBody>
-          <a:bodyPr wrap="square" lIns="0" tIns="0" rIns="0" bIns="0" rtlCol="0" anchor="t"/>
-          <a:lstStyle/>
-          <a:p>
-            <a:pPr indent="0" marL="0">
-              <a:lnSpc>
-                <a:spcPct val="110000"/>
-              </a:lnSpc>
-              <a:buNone/>
-            </a:pPr>
-            <a:r>
-              <a:rPr lang="en-US" sz="1500" dirty="0">
-                <a:solidFill>
-                  <a:schemeClr val="tx1"/>
-                </a:solidFill>
-              </a:rPr>
-              <a:t>Lee el pendiente, valida y escribe en DynamoDB sin duplicar. La web consulta el estado cada 2 s hasta 10 veces.</a:t>
-            </a:r>
-            <a:endParaRPr lang="en-US" sz="1500" dirty="0"/>
-          </a:p>
-        </p:txBody>
-      </p:sp>
+          <a:ln w="19050">
+            <a:solidFill>
+              <a:schemeClr val="accent1"/>
+            </a:solidFill>
+          </a:ln>
+        </p:spPr>
+      </p:sp>
+      <p:pic>
+        <p:nvPicPr>
+          <p:cNvPr id="27" name="img-secuencia.png" descr="Diagrama de secuencia de una publicación con imagen"/>
+          <p:cNvPicPr>
+            <a:picLocks noChangeAspect="1"/>
+          </p:cNvPicPr>
+          <p:nvPr/>
+        </p:nvPicPr>
+        <p:blipFill>
+          <a:blip r:embed="rId4"/>
+          <a:stretch>
+            <a:fillRect/>
+          </a:stretch>
+        </p:blipFill>
+        <p:spPr>
+          <a:xfrm>
+            <a:off x="2416210" y="1481328"/>
+            <a:ext cx="7359275" cy="4526280"/>
+          </a:xfrm>
+          <a:prstGeom prst="rect">
+            <a:avLst/>
+          </a:prstGeom>
+        </p:spPr>
+      </p:pic>
       <p:sp>
         <p:nvSpPr>
           <p:cNvPr id="25" name="Slide Number Placeholder 0"/>
@@ -13192,7 +11841,7 @@
       </p:sp>
       <p:pic>
         <p:nvPicPr>
-          <p:cNvPr id="5" name="img-logs-p01.png" descr="Logs de CloudWatch de la prueba P01">    </p:cNvPr>
+          <p:cNvPr id="5" name="img-logs-p01.png" descr="Logs de CloudWatch de la primera publicación">    </p:cNvPr>
           <p:cNvPicPr>
             <a:picLocks noChangeAspect="1"/>
           </p:cNvPicPr>
@@ -13244,7 +11893,7 @@
                   <a:schemeClr val="accent6"/>
                 </a:solidFill>
               </a:rPr>
-              <a:t>CloudWatch · /aws/lambda/procesar-imagen-noticia · prueba P01 (27 oct.)</a:t>
+              <a:t>CloudWatch · /aws/lambda/procesar-imagen-noticia · primera publicación (27 oct.)</a:t>
             </a:r>
             <a:endParaRPr lang="en-US" sz="1200" dirty="0"/>
           </a:p>
@@ -13720,7 +12369,7 @@
                   <a:schemeClr val="bg1"/>
                 </a:solidFill>
               </a:rPr>
-              <a:t>P01 + P02 ✓</a:t>
+              <a:t>Publicada ✓</a:t>
             </a:r>
             <a:endParaRPr lang="en-US" sz="1400" dirty="0"/>
           </a:p>

</xml_diff>